<commit_message>
up graficos burn up y down
</commit_message>
<xml_diff>
--- a/INCREMENTO3/Ppt/PPt Tercer incremento scrum++.pptx
+++ b/INCREMENTO3/Ppt/PPt Tercer incremento scrum++.pptx
@@ -217,7 +217,7 @@
           <a:p>
             <a:fld id="{56824AA8-F311-4ABC-8748-4A852C5A6ECD}" type="datetimeFigureOut">
               <a:rPr lang="es-419" smtClean="0"/>
-              <a:t>24/10/2025</a:t>
+              <a:t>26/10/2025</a:t>
             </a:fld>
             <a:endParaRPr lang="es-419"/>
           </a:p>
@@ -1363,7 +1363,7 @@
           <a:p>
             <a:fld id="{5BCAD085-E8A6-8845-BD4E-CB4CCA059FC4}" type="datetimeFigureOut">
               <a:rPr lang="en-US" smtClean="0"/>
-              <a:t>10/24/2025</a:t>
+              <a:t>10/26/2025</a:t>
             </a:fld>
             <a:endParaRPr lang="en-US"/>
           </a:p>
@@ -1614,7 +1614,7 @@
           <a:p>
             <a:fld id="{5BCAD085-E8A6-8845-BD4E-CB4CCA059FC4}" type="datetimeFigureOut">
               <a:rPr lang="en-US" smtClean="0"/>
-              <a:t>10/24/2025</a:t>
+              <a:t>10/26/2025</a:t>
             </a:fld>
             <a:endParaRPr lang="en-US"/>
           </a:p>
@@ -1928,7 +1928,7 @@
           <a:p>
             <a:fld id="{5BCAD085-E8A6-8845-BD4E-CB4CCA059FC4}" type="datetimeFigureOut">
               <a:rPr lang="en-US" smtClean="0"/>
-              <a:t>10/24/2025</a:t>
+              <a:t>10/26/2025</a:t>
             </a:fld>
             <a:endParaRPr lang="en-US"/>
           </a:p>
@@ -2261,7 +2261,7 @@
           <a:p>
             <a:fld id="{5BCAD085-E8A6-8845-BD4E-CB4CCA059FC4}" type="datetimeFigureOut">
               <a:rPr lang="en-US" smtClean="0"/>
-              <a:t>10/24/2025</a:t>
+              <a:t>10/26/2025</a:t>
             </a:fld>
             <a:endParaRPr lang="en-US"/>
           </a:p>
@@ -2575,7 +2575,7 @@
           <a:p>
             <a:fld id="{5BCAD085-E8A6-8845-BD4E-CB4CCA059FC4}" type="datetimeFigureOut">
               <a:rPr lang="en-US" smtClean="0"/>
-              <a:t>10/24/2025</a:t>
+              <a:t>10/26/2025</a:t>
             </a:fld>
             <a:endParaRPr lang="en-US"/>
           </a:p>
@@ -2968,7 +2968,7 @@
           <a:p>
             <a:fld id="{5BCAD085-E8A6-8845-BD4E-CB4CCA059FC4}" type="datetimeFigureOut">
               <a:rPr lang="en-US" smtClean="0"/>
-              <a:t>10/24/2025</a:t>
+              <a:t>10/26/2025</a:t>
             </a:fld>
             <a:endParaRPr lang="en-US"/>
           </a:p>
@@ -3138,7 +3138,7 @@
           <a:p>
             <a:fld id="{5BCAD085-E8A6-8845-BD4E-CB4CCA059FC4}" type="datetimeFigureOut">
               <a:rPr lang="en-US" smtClean="0"/>
-              <a:t>10/24/2025</a:t>
+              <a:t>10/26/2025</a:t>
             </a:fld>
             <a:endParaRPr lang="en-US"/>
           </a:p>
@@ -3318,7 +3318,7 @@
           <a:p>
             <a:fld id="{5BCAD085-E8A6-8845-BD4E-CB4CCA059FC4}" type="datetimeFigureOut">
               <a:rPr lang="en-US" smtClean="0"/>
-              <a:t>10/24/2025</a:t>
+              <a:t>10/26/2025</a:t>
             </a:fld>
             <a:endParaRPr lang="en-US"/>
           </a:p>
@@ -3488,7 +3488,7 @@
           <a:p>
             <a:fld id="{5BCAD085-E8A6-8845-BD4E-CB4CCA059FC4}" type="datetimeFigureOut">
               <a:rPr lang="en-US" smtClean="0"/>
-              <a:t>10/24/2025</a:t>
+              <a:t>10/26/2025</a:t>
             </a:fld>
             <a:endParaRPr lang="en-US"/>
           </a:p>
@@ -3735,7 +3735,7 @@
           <a:p>
             <a:fld id="{5BCAD085-E8A6-8845-BD4E-CB4CCA059FC4}" type="datetimeFigureOut">
               <a:rPr lang="en-US" smtClean="0"/>
-              <a:t>10/24/2025</a:t>
+              <a:t>10/26/2025</a:t>
             </a:fld>
             <a:endParaRPr lang="en-US"/>
           </a:p>
@@ -4032,7 +4032,7 @@
           <a:p>
             <a:fld id="{5BCAD085-E8A6-8845-BD4E-CB4CCA059FC4}" type="datetimeFigureOut">
               <a:rPr lang="en-US" smtClean="0"/>
-              <a:t>10/24/2025</a:t>
+              <a:t>10/26/2025</a:t>
             </a:fld>
             <a:endParaRPr lang="en-US"/>
           </a:p>
@@ -4411,7 +4411,7 @@
           <a:p>
             <a:fld id="{5BCAD085-E8A6-8845-BD4E-CB4CCA059FC4}" type="datetimeFigureOut">
               <a:rPr lang="en-US" smtClean="0"/>
-              <a:t>10/24/2025</a:t>
+              <a:t>10/26/2025</a:t>
             </a:fld>
             <a:endParaRPr lang="en-US"/>
           </a:p>
@@ -4534,7 +4534,7 @@
           <a:p>
             <a:fld id="{5BCAD085-E8A6-8845-BD4E-CB4CCA059FC4}" type="datetimeFigureOut">
               <a:rPr lang="en-US" smtClean="0"/>
-              <a:t>10/24/2025</a:t>
+              <a:t>10/26/2025</a:t>
             </a:fld>
             <a:endParaRPr lang="en-US"/>
           </a:p>
@@ -4629,7 +4629,7 @@
           <a:p>
             <a:fld id="{5BCAD085-E8A6-8845-BD4E-CB4CCA059FC4}" type="datetimeFigureOut">
               <a:rPr lang="en-US" smtClean="0"/>
-              <a:t>10/24/2025</a:t>
+              <a:t>10/26/2025</a:t>
             </a:fld>
             <a:endParaRPr lang="en-US"/>
           </a:p>
@@ -4884,7 +4884,7 @@
           <a:p>
             <a:fld id="{5BCAD085-E8A6-8845-BD4E-CB4CCA059FC4}" type="datetimeFigureOut">
               <a:rPr lang="en-US" smtClean="0"/>
-              <a:t>10/24/2025</a:t>
+              <a:t>10/26/2025</a:t>
             </a:fld>
             <a:endParaRPr lang="en-US"/>
           </a:p>
@@ -5147,7 +5147,7 @@
           <a:p>
             <a:fld id="{5BCAD085-E8A6-8845-BD4E-CB4CCA059FC4}" type="datetimeFigureOut">
               <a:rPr lang="en-US" smtClean="0"/>
-              <a:t>10/24/2025</a:t>
+              <a:t>10/26/2025</a:t>
             </a:fld>
             <a:endParaRPr lang="en-US"/>
           </a:p>
@@ -5305,6 +5305,13 @@
               <a:schemeClr val="lt1"/>
             </a:fontRef>
           </p:style>
+          <p:txBody>
+            <a:bodyPr/>
+            <a:lstStyle/>
+            <a:p>
+              <a:endParaRPr lang="es-CL"/>
+            </a:p>
+          </p:txBody>
         </p:sp>
         <p:cxnSp>
           <p:nvCxnSpPr>
@@ -5444,6 +5451,13 @@
               <a:schemeClr val="lt1"/>
             </a:fontRef>
           </p:style>
+          <p:txBody>
+            <a:bodyPr/>
+            <a:lstStyle/>
+            <a:p>
+              <a:endParaRPr lang="es-CL"/>
+            </a:p>
+          </p:txBody>
         </p:sp>
         <p:sp>
           <p:nvSpPr>
@@ -5509,6 +5523,13 @@
               <a:schemeClr val="lt1"/>
             </a:fontRef>
           </p:style>
+          <p:txBody>
+            <a:bodyPr/>
+            <a:lstStyle/>
+            <a:p>
+              <a:endParaRPr lang="es-CL"/>
+            </a:p>
+          </p:txBody>
         </p:sp>
         <p:sp>
           <p:nvSpPr>
@@ -5571,6 +5592,13 @@
               <a:schemeClr val="lt1"/>
             </a:fontRef>
           </p:style>
+          <p:txBody>
+            <a:bodyPr/>
+            <a:lstStyle/>
+            <a:p>
+              <a:endParaRPr lang="es-CL"/>
+            </a:p>
+          </p:txBody>
         </p:sp>
         <p:sp>
           <p:nvSpPr>
@@ -5635,6 +5663,13 @@
               <a:schemeClr val="lt1"/>
             </a:fontRef>
           </p:style>
+          <p:txBody>
+            <a:bodyPr/>
+            <a:lstStyle/>
+            <a:p>
+              <a:endParaRPr lang="es-CL"/>
+            </a:p>
+          </p:txBody>
         </p:sp>
         <p:sp>
           <p:nvSpPr>
@@ -5702,6 +5737,13 @@
               <a:schemeClr val="lt1"/>
             </a:fontRef>
           </p:style>
+          <p:txBody>
+            <a:bodyPr/>
+            <a:lstStyle/>
+            <a:p>
+              <a:endParaRPr lang="es-CL"/>
+            </a:p>
+          </p:txBody>
         </p:sp>
         <p:sp>
           <p:nvSpPr>
@@ -5767,6 +5809,13 @@
               <a:schemeClr val="lt1"/>
             </a:fontRef>
           </p:style>
+          <p:txBody>
+            <a:bodyPr/>
+            <a:lstStyle/>
+            <a:p>
+              <a:endParaRPr lang="es-CL"/>
+            </a:p>
+          </p:txBody>
         </p:sp>
         <p:sp>
           <p:nvSpPr>
@@ -5829,6 +5878,13 @@
               <a:schemeClr val="lt1"/>
             </a:fontRef>
           </p:style>
+          <p:txBody>
+            <a:bodyPr/>
+            <a:lstStyle/>
+            <a:p>
+              <a:endParaRPr lang="es-CL"/>
+            </a:p>
+          </p:txBody>
         </p:sp>
       </p:grpSp>
       <p:sp>
@@ -5961,7 +6017,7 @@
           <a:p>
             <a:fld id="{5BCAD085-E8A6-8845-BD4E-CB4CCA059FC4}" type="datetimeFigureOut">
               <a:rPr lang="en-US" smtClean="0"/>
-              <a:t>10/24/2025</a:t>
+              <a:t>10/26/2025</a:t>
             </a:fld>
             <a:endParaRPr lang="en-US"/>
           </a:p>
@@ -6508,7 +6564,7 @@
                 <a:latin typeface="Times New Roman" panose="02020603050405020304" pitchFamily="18" charset="0"/>
                 <a:cs typeface="Times New Roman" panose="02020603050405020304" pitchFamily="18" charset="0"/>
               </a:rPr>
-              <a:t>PROYECTO INGENIERÍA DE SOFTWARE SEGUNDO INCREMENTO PARA EL SISTEMA BIOMÉTRICO WEB EUGCOM</a:t>
+              <a:t>PROYECTO INGENIERÍA DE SOFTWARE TERCER INCREMENTO PARA EL SISTEMA BIOMÉTRICO WEB EUGCOM</a:t>
             </a:r>
             <a:endParaRPr lang="es-CL" sz="2000" dirty="0">
               <a:latin typeface="Times New Roman" panose="02020603050405020304" pitchFamily="18" charset="0"/>
@@ -7478,7 +7534,7 @@
           <a:p>
             <a:r>
               <a:rPr lang="es-CL" dirty="0"/>
-              <a:t>65</a:t>
+              <a:t>4</a:t>
             </a:r>
             <a:r>
               <a:rPr dirty="0"/>
@@ -7521,7 +7577,7 @@
             </a:r>
             <a:r>
               <a:rPr lang="es-CL" dirty="0"/>
-              <a:t>100</a:t>
+              <a:t>97</a:t>
             </a:r>
             <a:r>
               <a:rPr dirty="0"/>
@@ -7651,6 +7707,94 @@
           </a:p>
         </p:txBody>
       </p:sp>
+      <p:pic>
+        <p:nvPicPr>
+          <p:cNvPr id="6" name="Imagen 5" descr="Gráfico, Gráfico de barras, Histograma&#10;&#10;El contenido generado por IA puede ser incorrecto.">
+            <a:extLst>
+              <a:ext uri="{FF2B5EF4-FFF2-40B4-BE49-F238E27FC236}">
+                <a16:creationId xmlns:a16="http://schemas.microsoft.com/office/drawing/2014/main" id="{1B20F5EC-E599-5EDB-2EB2-6E17C05E072A}"/>
+              </a:ext>
+            </a:extLst>
+          </p:cNvPr>
+          <p:cNvPicPr>
+            <a:picLocks noChangeAspect="1"/>
+          </p:cNvPicPr>
+          <p:nvPr/>
+        </p:nvPicPr>
+        <p:blipFill>
+          <a:blip r:embed="rId4"/>
+          <a:stretch>
+            <a:fillRect/>
+          </a:stretch>
+        </p:blipFill>
+        <p:spPr>
+          <a:xfrm>
+            <a:off x="609599" y="3611593"/>
+            <a:ext cx="3191871" cy="2822663"/>
+          </a:xfrm>
+          <a:prstGeom prst="rect">
+            <a:avLst/>
+          </a:prstGeom>
+          <a:ln w="38100" cap="sq">
+            <a:solidFill>
+              <a:srgbClr val="000000"/>
+            </a:solidFill>
+            <a:prstDash val="solid"/>
+            <a:miter lim="800000"/>
+          </a:ln>
+          <a:effectLst>
+            <a:outerShdw blurRad="50800" dist="38100" dir="2700000" algn="tl" rotWithShape="0">
+              <a:srgbClr val="000000">
+                <a:alpha val="43000"/>
+              </a:srgbClr>
+            </a:outerShdw>
+          </a:effectLst>
+        </p:spPr>
+      </p:pic>
+      <p:pic>
+        <p:nvPicPr>
+          <p:cNvPr id="7" name="Imagen 6" descr="Gráfico, Gráfico circular&#10;&#10;El contenido generado por IA puede ser incorrecto.">
+            <a:extLst>
+              <a:ext uri="{FF2B5EF4-FFF2-40B4-BE49-F238E27FC236}">
+                <a16:creationId xmlns:a16="http://schemas.microsoft.com/office/drawing/2014/main" id="{66652064-34CB-6169-3E2B-0308C5E5C8B9}"/>
+              </a:ext>
+            </a:extLst>
+          </p:cNvPr>
+          <p:cNvPicPr>
+            <a:picLocks noChangeAspect="1"/>
+          </p:cNvPicPr>
+          <p:nvPr/>
+        </p:nvPicPr>
+        <p:blipFill>
+          <a:blip r:embed="rId5"/>
+          <a:stretch>
+            <a:fillRect/>
+          </a:stretch>
+        </p:blipFill>
+        <p:spPr>
+          <a:xfrm>
+            <a:off x="4459350" y="3659190"/>
+            <a:ext cx="2616456" cy="2802544"/>
+          </a:xfrm>
+          <a:prstGeom prst="rect">
+            <a:avLst/>
+          </a:prstGeom>
+          <a:ln w="38100" cap="sq">
+            <a:solidFill>
+              <a:srgbClr val="000000"/>
+            </a:solidFill>
+            <a:prstDash val="solid"/>
+            <a:miter lim="800000"/>
+          </a:ln>
+          <a:effectLst>
+            <a:outerShdw blurRad="50800" dist="38100" dir="2700000" algn="tl" rotWithShape="0">
+              <a:srgbClr val="000000">
+                <a:alpha val="43000"/>
+              </a:srgbClr>
+            </a:outerShdw>
+          </a:effectLst>
+        </p:spPr>
+      </p:pic>
     </p:spTree>
   </p:cSld>
   <p:clrMapOvr>

</xml_diff>